<commit_message>
ADD: n-step window tex
</commit_message>
<xml_diff>
--- a/single-agent/figs/n-step-windows.pptx
+++ b/single-agent/figs/n-step-windows.pptx
@@ -134,7 +134,7 @@
 <file path=ppt/revisionInfo.xml><?xml version="1.0" encoding="utf-8"?>
 <p1510:revInfo xmlns:a="http://schemas.openxmlformats.org/drawingml/2006/main" xmlns:r="http://schemas.openxmlformats.org/officeDocument/2006/relationships" xmlns:p1510="http://schemas.microsoft.com/office/powerpoint/2015/10/main">
   <p1510:revLst>
-    <p1510:client id="{CA7329C7-3752-41AF-AF4E-903DEFE77B52}" v="16" dt="2023-11-03T06:06:40.573"/>
+    <p1510:client id="{CA7329C7-3752-41AF-AF4E-903DEFE77B52}" v="22" dt="2023-11-04T03:04:38.722"/>
   </p1510:revLst>
 </p1510:revInfo>
 </file>
@@ -144,16 +144,72 @@
   <pc:docChgLst>
     <pc:chgData name="Tim Miller" userId="e118c78a-470c-4863-8b52-3aa598a6a1d5" providerId="ADAL" clId="{CA7329C7-3752-41AF-AF4E-903DEFE77B52}"/>
     <pc:docChg chg="undo custSel addSld delSld modSld">
-      <pc:chgData name="Tim Miller" userId="e118c78a-470c-4863-8b52-3aa598a6a1d5" providerId="ADAL" clId="{CA7329C7-3752-41AF-AF4E-903DEFE77B52}" dt="2023-11-03T06:10:42.047" v="447" actId="1035"/>
+      <pc:chgData name="Tim Miller" userId="e118c78a-470c-4863-8b52-3aa598a6a1d5" providerId="ADAL" clId="{CA7329C7-3752-41AF-AF4E-903DEFE77B52}" dt="2023-11-04T03:04:53.993" v="460" actId="478"/>
       <pc:docMkLst>
         <pc:docMk/>
       </pc:docMkLst>
       <pc:sldChg chg="addSp delSp modSp mod">
-        <pc:chgData name="Tim Miller" userId="e118c78a-470c-4863-8b52-3aa598a6a1d5" providerId="ADAL" clId="{CA7329C7-3752-41AF-AF4E-903DEFE77B52}" dt="2023-11-03T06:03:38.797" v="23" actId="14100"/>
+        <pc:chgData name="Tim Miller" userId="e118c78a-470c-4863-8b52-3aa598a6a1d5" providerId="ADAL" clId="{CA7329C7-3752-41AF-AF4E-903DEFE77B52}" dt="2023-11-04T03:04:53.993" v="460" actId="478"/>
         <pc:sldMkLst>
           <pc:docMk/>
           <pc:sldMk cId="1066655576" sldId="256"/>
         </pc:sldMkLst>
+        <pc:spChg chg="add">
+          <ac:chgData name="Tim Miller" userId="e118c78a-470c-4863-8b52-3aa598a6a1d5" providerId="ADAL" clId="{CA7329C7-3752-41AF-AF4E-903DEFE77B52}" dt="2023-11-04T03:04:33.984" v="448" actId="11529"/>
+          <ac:spMkLst>
+            <pc:docMk/>
+            <pc:sldMk cId="1066655576" sldId="256"/>
+            <ac:spMk id="2" creationId="{48C32FA7-1884-CB4B-C7FB-7D37F6A1066F}"/>
+          </ac:spMkLst>
+        </pc:spChg>
+        <pc:spChg chg="add mod">
+          <ac:chgData name="Tim Miller" userId="e118c78a-470c-4863-8b52-3aa598a6a1d5" providerId="ADAL" clId="{CA7329C7-3752-41AF-AF4E-903DEFE77B52}" dt="2023-11-04T03:04:41.653" v="455" actId="1076"/>
+          <ac:spMkLst>
+            <pc:docMk/>
+            <pc:sldMk cId="1066655576" sldId="256"/>
+            <ac:spMk id="4" creationId="{065CB852-D4F5-2ACF-89EB-A6097FF99576}"/>
+          </ac:spMkLst>
+        </pc:spChg>
+        <pc:spChg chg="add mod">
+          <ac:chgData name="Tim Miller" userId="e118c78a-470c-4863-8b52-3aa598a6a1d5" providerId="ADAL" clId="{CA7329C7-3752-41AF-AF4E-903DEFE77B52}" dt="2023-11-04T03:04:43.658" v="456" actId="1076"/>
+          <ac:spMkLst>
+            <pc:docMk/>
+            <pc:sldMk cId="1066655576" sldId="256"/>
+            <ac:spMk id="5" creationId="{6D498904-CF68-F88A-52F6-8613C02A0BFB}"/>
+          </ac:spMkLst>
+        </pc:spChg>
+        <pc:spChg chg="add mod">
+          <ac:chgData name="Tim Miller" userId="e118c78a-470c-4863-8b52-3aa598a6a1d5" providerId="ADAL" clId="{CA7329C7-3752-41AF-AF4E-903DEFE77B52}" dt="2023-11-04T03:04:46.084" v="457" actId="1076"/>
+          <ac:spMkLst>
+            <pc:docMk/>
+            <pc:sldMk cId="1066655576" sldId="256"/>
+            <ac:spMk id="6" creationId="{B4EF1A85-FC22-3CFD-67B9-4E24B8CCEF82}"/>
+          </ac:spMkLst>
+        </pc:spChg>
+        <pc:spChg chg="add mod">
+          <ac:chgData name="Tim Miller" userId="e118c78a-470c-4863-8b52-3aa598a6a1d5" providerId="ADAL" clId="{CA7329C7-3752-41AF-AF4E-903DEFE77B52}" dt="2023-11-04T03:04:48.703" v="458" actId="1076"/>
+          <ac:spMkLst>
+            <pc:docMk/>
+            <pc:sldMk cId="1066655576" sldId="256"/>
+            <ac:spMk id="18" creationId="{9B6BD122-8591-6503-FACF-BA5359E4CBB4}"/>
+          </ac:spMkLst>
+        </pc:spChg>
+        <pc:spChg chg="add mod">
+          <ac:chgData name="Tim Miller" userId="e118c78a-470c-4863-8b52-3aa598a6a1d5" providerId="ADAL" clId="{CA7329C7-3752-41AF-AF4E-903DEFE77B52}" dt="2023-11-04T03:04:51.806" v="459" actId="1076"/>
+          <ac:spMkLst>
+            <pc:docMk/>
+            <pc:sldMk cId="1066655576" sldId="256"/>
+            <ac:spMk id="19" creationId="{4225177C-E146-67C9-78E0-477271AFC707}"/>
+          </ac:spMkLst>
+        </pc:spChg>
+        <pc:spChg chg="add del mod">
+          <ac:chgData name="Tim Miller" userId="e118c78a-470c-4863-8b52-3aa598a6a1d5" providerId="ADAL" clId="{CA7329C7-3752-41AF-AF4E-903DEFE77B52}" dt="2023-11-04T03:04:53.993" v="460" actId="478"/>
+          <ac:spMkLst>
+            <pc:docMk/>
+            <pc:sldMk cId="1066655576" sldId="256"/>
+            <ac:spMk id="24" creationId="{1BDA0402-3F15-458A-E47C-6D2FE5AB45B7}"/>
+          </ac:spMkLst>
+        </pc:spChg>
         <pc:cxnChg chg="add mod">
           <ac:chgData name="Tim Miller" userId="e118c78a-470c-4863-8b52-3aa598a6a1d5" providerId="ADAL" clId="{CA7329C7-3752-41AF-AF4E-903DEFE77B52}" dt="2023-11-03T06:03:38.797" v="23" actId="14100"/>
           <ac:cxnSpMkLst>
@@ -5732,6 +5788,282 @@
           </a:fontRef>
         </p:style>
       </p:cxnSp>
+      <p:sp>
+        <p:nvSpPr>
+          <p:cNvPr id="2" name="Oval 1">
+            <a:extLst>
+              <a:ext uri="{FF2B5EF4-FFF2-40B4-BE49-F238E27FC236}">
+                <a16:creationId xmlns:a16="http://schemas.microsoft.com/office/drawing/2014/main" id="{48C32FA7-1884-CB4B-C7FB-7D37F6A1066F}"/>
+              </a:ext>
+            </a:extLst>
+          </p:cNvPr>
+          <p:cNvSpPr/>
+          <p:nvPr/>
+        </p:nvSpPr>
+        <p:spPr>
+          <a:xfrm>
+            <a:off x="1508125" y="596630"/>
+            <a:ext cx="210428" cy="232558"/>
+          </a:xfrm>
+          <a:prstGeom prst="ellipse">
+            <a:avLst/>
+          </a:prstGeom>
+        </p:spPr>
+        <p:style>
+          <a:lnRef idx="2">
+            <a:schemeClr val="accent1">
+              <a:shade val="15000"/>
+            </a:schemeClr>
+          </a:lnRef>
+          <a:fillRef idx="1">
+            <a:schemeClr val="accent1"/>
+          </a:fillRef>
+          <a:effectRef idx="0">
+            <a:schemeClr val="accent1"/>
+          </a:effectRef>
+          <a:fontRef idx="minor">
+            <a:schemeClr val="lt1"/>
+          </a:fontRef>
+        </p:style>
+        <p:txBody>
+          <a:bodyPr rtlCol="0" anchor="ctr"/>
+          <a:lstStyle/>
+          <a:p>
+            <a:pPr algn="ctr"/>
+            <a:endParaRPr lang="en-AU"/>
+          </a:p>
+        </p:txBody>
+      </p:sp>
+      <p:sp>
+        <p:nvSpPr>
+          <p:cNvPr id="4" name="Oval 3">
+            <a:extLst>
+              <a:ext uri="{FF2B5EF4-FFF2-40B4-BE49-F238E27FC236}">
+                <a16:creationId xmlns:a16="http://schemas.microsoft.com/office/drawing/2014/main" id="{065CB852-D4F5-2ACF-89EB-A6097FF99576}"/>
+              </a:ext>
+            </a:extLst>
+          </p:cNvPr>
+          <p:cNvSpPr/>
+          <p:nvPr/>
+        </p:nvSpPr>
+        <p:spPr>
+          <a:xfrm>
+            <a:off x="2375339" y="565590"/>
+            <a:ext cx="210428" cy="232558"/>
+          </a:xfrm>
+          <a:prstGeom prst="ellipse">
+            <a:avLst/>
+          </a:prstGeom>
+        </p:spPr>
+        <p:style>
+          <a:lnRef idx="2">
+            <a:schemeClr val="accent1">
+              <a:shade val="15000"/>
+            </a:schemeClr>
+          </a:lnRef>
+          <a:fillRef idx="1">
+            <a:schemeClr val="accent1"/>
+          </a:fillRef>
+          <a:effectRef idx="0">
+            <a:schemeClr val="accent1"/>
+          </a:effectRef>
+          <a:fontRef idx="minor">
+            <a:schemeClr val="lt1"/>
+          </a:fontRef>
+        </p:style>
+        <p:txBody>
+          <a:bodyPr rtlCol="0" anchor="ctr"/>
+          <a:lstStyle/>
+          <a:p>
+            <a:pPr algn="ctr"/>
+            <a:endParaRPr lang="en-AU"/>
+          </a:p>
+        </p:txBody>
+      </p:sp>
+      <p:sp>
+        <p:nvSpPr>
+          <p:cNvPr id="5" name="Oval 4">
+            <a:extLst>
+              <a:ext uri="{FF2B5EF4-FFF2-40B4-BE49-F238E27FC236}">
+                <a16:creationId xmlns:a16="http://schemas.microsoft.com/office/drawing/2014/main" id="{6D498904-CF68-F88A-52F6-8613C02A0BFB}"/>
+              </a:ext>
+            </a:extLst>
+          </p:cNvPr>
+          <p:cNvSpPr/>
+          <p:nvPr/>
+        </p:nvSpPr>
+        <p:spPr>
+          <a:xfrm>
+            <a:off x="3242553" y="563874"/>
+            <a:ext cx="210428" cy="232558"/>
+          </a:xfrm>
+          <a:prstGeom prst="ellipse">
+            <a:avLst/>
+          </a:prstGeom>
+        </p:spPr>
+        <p:style>
+          <a:lnRef idx="2">
+            <a:schemeClr val="accent1">
+              <a:shade val="15000"/>
+            </a:schemeClr>
+          </a:lnRef>
+          <a:fillRef idx="1">
+            <a:schemeClr val="accent1"/>
+          </a:fillRef>
+          <a:effectRef idx="0">
+            <a:schemeClr val="accent1"/>
+          </a:effectRef>
+          <a:fontRef idx="minor">
+            <a:schemeClr val="lt1"/>
+          </a:fontRef>
+        </p:style>
+        <p:txBody>
+          <a:bodyPr rtlCol="0" anchor="ctr"/>
+          <a:lstStyle/>
+          <a:p>
+            <a:pPr algn="ctr"/>
+            <a:endParaRPr lang="en-AU"/>
+          </a:p>
+        </p:txBody>
+      </p:sp>
+      <p:sp>
+        <p:nvSpPr>
+          <p:cNvPr id="6" name="Oval 5">
+            <a:extLst>
+              <a:ext uri="{FF2B5EF4-FFF2-40B4-BE49-F238E27FC236}">
+                <a16:creationId xmlns:a16="http://schemas.microsoft.com/office/drawing/2014/main" id="{B4EF1A85-FC22-3CFD-67B9-4E24B8CCEF82}"/>
+              </a:ext>
+            </a:extLst>
+          </p:cNvPr>
+          <p:cNvSpPr/>
+          <p:nvPr/>
+        </p:nvSpPr>
+        <p:spPr>
+          <a:xfrm>
+            <a:off x="4158810" y="462432"/>
+            <a:ext cx="210428" cy="232558"/>
+          </a:xfrm>
+          <a:prstGeom prst="ellipse">
+            <a:avLst/>
+          </a:prstGeom>
+        </p:spPr>
+        <p:style>
+          <a:lnRef idx="2">
+            <a:schemeClr val="accent1">
+              <a:shade val="15000"/>
+            </a:schemeClr>
+          </a:lnRef>
+          <a:fillRef idx="1">
+            <a:schemeClr val="accent1"/>
+          </a:fillRef>
+          <a:effectRef idx="0">
+            <a:schemeClr val="accent1"/>
+          </a:effectRef>
+          <a:fontRef idx="minor">
+            <a:schemeClr val="lt1"/>
+          </a:fontRef>
+        </p:style>
+        <p:txBody>
+          <a:bodyPr rtlCol="0" anchor="ctr"/>
+          <a:lstStyle/>
+          <a:p>
+            <a:pPr algn="ctr"/>
+            <a:endParaRPr lang="en-AU"/>
+          </a:p>
+        </p:txBody>
+      </p:sp>
+      <p:sp>
+        <p:nvSpPr>
+          <p:cNvPr id="18" name="Oval 17">
+            <a:extLst>
+              <a:ext uri="{FF2B5EF4-FFF2-40B4-BE49-F238E27FC236}">
+                <a16:creationId xmlns:a16="http://schemas.microsoft.com/office/drawing/2014/main" id="{9B6BD122-8591-6503-FACF-BA5359E4CBB4}"/>
+              </a:ext>
+            </a:extLst>
+          </p:cNvPr>
+          <p:cNvSpPr/>
+          <p:nvPr/>
+        </p:nvSpPr>
+        <p:spPr>
+          <a:xfrm>
+            <a:off x="5075067" y="531814"/>
+            <a:ext cx="210428" cy="232558"/>
+          </a:xfrm>
+          <a:prstGeom prst="ellipse">
+            <a:avLst/>
+          </a:prstGeom>
+        </p:spPr>
+        <p:style>
+          <a:lnRef idx="2">
+            <a:schemeClr val="accent1">
+              <a:shade val="15000"/>
+            </a:schemeClr>
+          </a:lnRef>
+          <a:fillRef idx="1">
+            <a:schemeClr val="accent1"/>
+          </a:fillRef>
+          <a:effectRef idx="0">
+            <a:schemeClr val="accent1"/>
+          </a:effectRef>
+          <a:fontRef idx="minor">
+            <a:schemeClr val="lt1"/>
+          </a:fontRef>
+        </p:style>
+        <p:txBody>
+          <a:bodyPr rtlCol="0" anchor="ctr"/>
+          <a:lstStyle/>
+          <a:p>
+            <a:pPr algn="ctr"/>
+            <a:endParaRPr lang="en-AU"/>
+          </a:p>
+        </p:txBody>
+      </p:sp>
+      <p:sp>
+        <p:nvSpPr>
+          <p:cNvPr id="19" name="Oval 18">
+            <a:extLst>
+              <a:ext uri="{FF2B5EF4-FFF2-40B4-BE49-F238E27FC236}">
+                <a16:creationId xmlns:a16="http://schemas.microsoft.com/office/drawing/2014/main" id="{4225177C-E146-67C9-78E0-477271AFC707}"/>
+              </a:ext>
+            </a:extLst>
+          </p:cNvPr>
+          <p:cNvSpPr/>
+          <p:nvPr/>
+        </p:nvSpPr>
+        <p:spPr>
+          <a:xfrm>
+            <a:off x="5973560" y="523117"/>
+            <a:ext cx="210428" cy="232558"/>
+          </a:xfrm>
+          <a:prstGeom prst="ellipse">
+            <a:avLst/>
+          </a:prstGeom>
+        </p:spPr>
+        <p:style>
+          <a:lnRef idx="2">
+            <a:schemeClr val="accent1">
+              <a:shade val="15000"/>
+            </a:schemeClr>
+          </a:lnRef>
+          <a:fillRef idx="1">
+            <a:schemeClr val="accent1"/>
+          </a:fillRef>
+          <a:effectRef idx="0">
+            <a:schemeClr val="accent1"/>
+          </a:effectRef>
+          <a:fontRef idx="minor">
+            <a:schemeClr val="lt1"/>
+          </a:fontRef>
+        </p:style>
+        <p:txBody>
+          <a:bodyPr rtlCol="0" anchor="ctr"/>
+          <a:lstStyle/>
+          <a:p>
+            <a:pPr algn="ctr"/>
+            <a:endParaRPr lang="en-AU"/>
+          </a:p>
+        </p:txBody>
+      </p:sp>
     </p:spTree>
     <p:extLst>
       <p:ext uri="{BB962C8B-B14F-4D97-AF65-F5344CB8AC3E}">

</xml_diff>